<commit_message>
docs: update slide 5 preprocessing flow to show parametric W=1024 defaults
The preprocessing flow boxes hardcoded "2048 × 1636" and "2048 × 1536"
which referred to the old 2048px pipeline. With default --preprocess_width=1024
the actual output is 1024×768. Updated labels to show the formula and the
1024-based defaults, consistent with the pipeline PDF diagram.

Co-Authored-By: Claude Sonnet 4.6 <noreply@anthropic.com>
</commit_message>
<xml_diff>
--- a/gate_review_precursor.pptx
+++ b/gate_review_precursor.pptx
@@ -20213,8 +20213,8 @@
                 </a:solidFill>
                 <a:latin typeface="맑은 고딕"/>
               </a:rPr>
-              <a:t>리사이즈
-2048 × 1636</a:t>
+              <a:t>리사이즈  (--preprocess_width W)
+기본 W=1024  →  1024 × 818</a:t>
             </a:r>
           </a:p>
         </p:txBody>
@@ -20305,8 +20305,8 @@
                 </a:solidFill>
                 <a:latin typeface="맑은 고딕"/>
               </a:rPr>
-              <a:t>하단 100px 크롭
-(스케일바 제거)</a:t>
+              <a:t>하단 크롭  (스케일바 제거)
+기본 round(W·100/2048)=50 px</a:t>
             </a:r>
           </a:p>
         </p:txBody>
@@ -20397,8 +20397,8 @@
                 </a:solidFill>
                 <a:latin typeface="맑은 고딕"/>
               </a:rPr>
-              <a:t>출력: 2048 × 1536
-(고정 해상도)</a:t>
+              <a:t>출력 (기본)
+1024 × 768</a:t>
             </a:r>
           </a:p>
         </p:txBody>

</xml_diff>

<commit_message>
revert: restore PPTX domain convention — 1차=spherical, 2차=acicular
Slides 6 and 11 had been changed to apply the code's English naming
(primary_measure.py→1차, secondary_measure.py→2차) which contradicts
the PPTX's own domain convention established in slides 3–4:
  1차 입자 = 구형 전구체 (spherical, secondary_measure.py)
  2차 입자 = 개별 결정/침상 (acicular, primary_measure.py)

Reverting to the PPTX-consistent labels to prevent internal contradiction.

Co-Authored-By: Claude Sonnet 4.6 <noreply@anthropic.com>
</commit_message>
<xml_diff>
--- a/gate_review_precursor.pptx
+++ b/gate_review_precursor.pptx
@@ -20784,7 +20784,7 @@
                 </a:solidFill>
                 <a:latin typeface="맑은 고딕"/>
               </a:rPr>
-              <a:t>2차 입자 파이프라인</a:t>
+              <a:t>1차 입자 파이프라인</a:t>
             </a:r>
           </a:p>
           <a:p>
@@ -21526,7 +21526,7 @@
                 </a:solidFill>
                 <a:latin typeface="맑은 고딕"/>
               </a:rPr>
-              <a:t>1차 입자 파이프라인</a:t>
+              <a:t>2차 입자 파이프라인</a:t>
             </a:r>
           </a:p>
           <a:p>

</xml_diff>